<commit_message>
Semana 12: presentación alineada con la versión actual de la app
</commit_message>
<xml_diff>
--- a/deliveries/week12/PresentationWeek12.pptx
+++ b/deliveries/week12/PresentationWeek12.pptx
@@ -7804,7 +7804,7 @@
                           <a:cs typeface="Arial"/>
                           <a:sym typeface="Arial"/>
                         </a:rPr>
-                        <a:t>Mapa coroplético por proporción + filtros de fuente y año</a:t>
+                        <a:t>Mapa del índice ajustado por fuente y año + brush de periodo</a:t>
                       </a:r>
                       <a:endParaRPr lang="en-US" sz="1100"/>
                     </a:p>
@@ -8352,7 +8352,7 @@
                           <a:cs typeface="Arial"/>
                           <a:sym typeface="Arial"/>
                         </a:rPr>
-                        <a:t>Reloj de 24 h + líneas lunes–viernes vs. fin de semana</a:t>
+                        <a:t>Heatmap de hora × día + reloj de 24 h</a:t>
                       </a:r>
                       <a:endParaRPr lang="en-US" sz="1100"/>
                     </a:p>
@@ -8909,7 +8909,7 @@
                           <a:cs typeface="Arial"/>
                           <a:sym typeface="Arial"/>
                         </a:rPr>
-                        <a:t>Opción para comparar estados/ciudades</a:t>
+                        <a:t>Fijar A y B: comparar dos estados o condados</a:t>
                       </a:r>
                       <a:endParaRPr lang="en-US" sz="1100"/>
                     </a:p>
@@ -10151,7 +10151,7 @@
                 <a:cs typeface="Arial"/>
                 <a:sym typeface="Arial"/>
               </a:rPr>
-              <a:t>Navegación USA → estado → condado → ciudad, y las líneas lunes–viernes vs. fin de semana (T3).</a:t>
+              <a:t>Navegación USA → estado → condado → ciudad, y laborables frente a fin de semana en el heatmap (T3).</a:t>
             </a:r>
           </a:p>
         </p:txBody>
@@ -10327,7 +10327,7 @@
                 <a:cs typeface="Arial"/>
                 <a:sym typeface="Arial"/>
               </a:rPr>
-              <a:t>Filtros compartidos de estado, fuente y año, y el mapa coloreado por proporción (T1).</a:t>
+              <a:t>Filtros compartidos de fuente y periodo, y el mapa coloreado por el índice ajustado (T1).</a:t>
             </a:r>
           </a:p>
         </p:txBody>
@@ -10503,7 +10503,7 @@
                 <a:cs typeface="Arial"/>
                 <a:sym typeface="Arial"/>
               </a:rPr>
-              <a:t>Mapa Mapbox como entrada; al seleccionar un área se actualizan totales, RadViz y líneas.</a:t>
+              <a:t>Mapa Mapbox como entrada y vías coloreadas según los accidentes, como un mapa de tráfico.</a:t>
             </a:r>
           </a:p>
         </p:txBody>
@@ -10679,7 +10679,7 @@
                 <a:cs typeface="Arial"/>
                 <a:sym typeface="Arial"/>
               </a:rPr>
-              <a:t>Lazo en el mapa que filtra a la vez el RadViz (vista multivariable) y las líneas por hora.</a:t>
+              <a:t>Una sola pantalla: panel, mapa, columna de vistas enlazadas y brush de tiempo abajo.</a:t>
             </a:r>
           </a:p>
         </p:txBody>
@@ -11967,7 +11967,7 @@
                           <a:cs typeface="Arial Bold"/>
                           <a:sym typeface="Arial Bold"/>
                         </a:rPr>
-                        <a:t>Mapa por proporción severidad ≥ 3 / total</a:t>
+                        <a:t>Mapa por índice ajustado (observados ÷ esperados)</a:t>
                       </a:r>
                       <a:endParaRPr lang="en-US" sz="1100"/>
                     </a:p>
@@ -12115,7 +12115,7 @@
                           <a:cs typeface="Arial"/>
                           <a:sym typeface="Arial"/>
                         </a:rPr>
-                        <a:t>Conteo absoluto: destacaría a los estados con más registros</a:t>
+                        <a:t>Proporción bruta o conteo: premia a la fuente que marca más alto o a los estados con más registros</a:t>
                       </a:r>
                       <a:endParaRPr lang="en-US" sz="1100"/>
                     </a:p>
@@ -13940,7 +13940,7 @@
                           <a:cs typeface="Arial"/>
                           <a:sym typeface="Arial"/>
                         </a:rPr>
-                        <a:t>El lazo esta limitado a 5km a la redonda</a:t>
+                        <a:t>El lazo está limitado a 5 km a la redonda</a:t>
                       </a:r>
                       <a:endParaRPr lang="en-US" sz="1100"/>
                     </a:p>
@@ -14010,7 +14010,7 @@
                           <a:cs typeface="Arial Bold"/>
                           <a:sym typeface="Arial Bold"/>
                         </a:rPr>
-                        <a:t>Mejorar la visualizacion de los condados </a:t>
+                        <a:t>Mejorar la visualización de los condados </a:t>
                       </a:r>
                       <a:endParaRPr lang="en-US" sz="1100"/>
                     </a:p>
@@ -14078,7 +14078,7 @@
                           <a:cs typeface="Arial"/>
                           <a:sym typeface="Arial"/>
                         </a:rPr>
-                        <a:t>visualizacion del mapa optimizado</a:t>
+                        <a:t>Visualización del mapa optimizada</a:t>
                       </a:r>
                       <a:endParaRPr lang="en-US" sz="1100"/>
                     </a:p>
@@ -14216,7 +14216,7 @@
                           <a:cs typeface="Arial"/>
                           <a:sym typeface="Arial"/>
                         </a:rPr>
-                        <a:t>Se agregó la visualizacion de Timeline con Brush</a:t>
+                        <a:t>Se agregó la línea de tiempo con brush</a:t>
                       </a:r>
                       <a:endParaRPr lang="en-US" sz="1100"/>
                     </a:p>
@@ -14354,7 +14354,7 @@
                           <a:cs typeface="Arial"/>
                           <a:sym typeface="Arial"/>
                         </a:rPr>
-                        <a:t>Agregado en la vizualiacion del mapa</a:t>
+                        <a:t>Agregado en la visualización del mapa</a:t>
                       </a:r>
                       <a:endParaRPr lang="en-US" sz="1100"/>
                     </a:p>
@@ -14406,6 +14406,60 @@
           </a:graphicData>
         </a:graphic>
       </p:graphicFrame>
+      <p:grpSp>
+        <p:nvGrpSpPr>
+          <p:cNvPr name="Group Title" id="15"/>
+          <p:cNvGrpSpPr/>
+          <p:nvPr/>
+        </p:nvGrpSpPr>
+        <p:grpSpPr>
+          <a:xfrm rot="0">
+            <a:off x="617706" y="617706"/>
+            <a:ext cx="17021137" cy="1372676"/>
+            <a:chOff x="0" y="0"/>
+            <a:chExt cx="22694849" cy="1830235"/>
+          </a:xfrm>
+        </p:grpSpPr>
+        <p:sp>
+          <p:nvSpPr>
+            <p:cNvPr name="TextBox 11" id="14"/>
+            <p:cNvSpPr txBox="true"/>
+            <p:nvPr/>
+          </p:nvSpPr>
+          <p:spPr>
+            <a:xfrm>
+              <a:off x="0" y="-19050"/>
+              <a:ext cx="22694849" cy="1849285"/>
+            </a:xfrm>
+            <a:prstGeom prst="rect">
+              <a:avLst/>
+            </a:prstGeom>
+          </p:spPr>
+          <p:txBody>
+            <a:bodyPr anchor="ctr" rtlCol="false" tIns="0" lIns="0" bIns="0" rIns="0"/>
+            <a:lstStyle/>
+            <a:p>
+              <a:pPr algn="l">
+                <a:lnSpc>
+                  <a:spcPts val="5043"/>
+                </a:lnSpc>
+              </a:pPr>
+              <a:r>
+                <a:rPr lang="en-US" sz="4203" b="true">
+                  <a:solidFill>
+                    <a:srgbClr val="141414"/>
+                  </a:solidFill>
+                  <a:latin typeface="Arial Bold"/>
+                  <a:ea typeface="Arial Bold"/>
+                  <a:cs typeface="Arial Bold"/>
+                  <a:sym typeface="Arial Bold"/>
+                </a:rPr>
+                <a:t>FEEDBACK DEL DESIGN REVIEW Y RESPUESTA</a:t>
+              </a:r>
+            </a:p>
+          </p:txBody>
+        </p:sp>
+      </p:grpSp>
     </p:spTree>
   </p:cSld>
   <p:clrMapOvr>

</xml_diff>